<commit_message>
Convert presentation notes to script format
</commit_message>
<xml_diff>
--- a/Support_Excellence_Program.pptx
+++ b/Support_Excellence_Program.pptx
@@ -271,7 +271,7 @@
 </file>
 
 <file path=ppt/notesSlides/notesSlide1.xml><?xml version="1.0" encoding="utf-8"?>
-<p:notes xmlns:a="http://schemas.openxmlformats.org/drawingml/2006/main" xmlns:r="http://schemas.openxmlformats.org/officeDocument/2006/relationships" xmlns:p="http://schemas.openxmlformats.org/presentationml/2006/main">
+<p:notes xmlns:a="http://schemas.openxmlformats.org/drawingml/2006/main" xmlns:p="http://schemas.openxmlformats.org/presentationml/2006/main">
   <p:cSld>
     <p:spTree>
       <p:nvGrpSpPr>
@@ -315,26 +315,26 @@
           <a:lstStyle/>
           <a:p>
             <a:r>
-              <a:rPr sz="1100">
-                <a:latin typeface="Aptos"/>
-              </a:rPr>
-              <a:t>Open the session by positioning this as a practical enablement program, not a theoretical lecture. The purpose is to help L1 Support resolve more issues independently and make the escalations that do reach Development faster to investigate.</a:t>
-            </a:r>
-          </a:p>
-          <a:p>
-            <a:r>
-              <a:rPr sz="1100">
-                <a:latin typeface="Aptos"/>
-              </a:rPr>
-              <a:t>Set expectations for participation. Ask attendees to think about recent escalations that took too long, had missing information, or bounced between teams. Explain that the deck will use those real patterns to build a consistent troubleshooting and escalation standard.</a:t>
-            </a:r>
-          </a:p>
-          <a:p>
-            <a:r>
-              <a:rPr sz="1100">
-                <a:latin typeface="Aptos"/>
-              </a:rPr>
-              <a:t>Emphasize that Support and Development are on the same side: faster customer resolution. The workflow is not about blocking escalations; it is about making sure every escalation is actionable.</a:t>
+              <a:rPr sz="1100" dirty="0">
+                <a:latin typeface="Aptos"/>
+              </a:rPr>
+              <a:t>Welcome everyone. Today’s session is a practical enablement program for L1 Support. The goal is to help us resolve more issues independently and make the escalations that do reach Development much faster to investigate.</a:t>
+            </a:r>
+          </a:p>
+          <a:p>
+            <a:r>
+              <a:rPr sz="1100" dirty="0">
+                <a:latin typeface="Aptos"/>
+              </a:rPr>
+              <a:t>As we go through the deck, think about recent escalations that took too long, had missing information, or bounced between teams. We will use those real patterns to build a consistent troubleshooting and escalation standard.</a:t>
+            </a:r>
+          </a:p>
+          <a:p>
+            <a:r>
+              <a:rPr sz="1100" dirty="0">
+                <a:latin typeface="Aptos"/>
+              </a:rPr>
+              <a:t>Support and Development are on the same side: faster customer resolution. This workflow is not about blocking escalations; it is about making every escalation actionable.</a:t>
             </a:r>
           </a:p>
         </p:txBody>
@@ -360,7 +360,7 @@
 </file>
 
 <file path=ppt/notesSlides/notesSlide10.xml><?xml version="1.0" encoding="utf-8"?>
-<p:notes xmlns:a="http://schemas.openxmlformats.org/drawingml/2006/main" xmlns:r="http://schemas.openxmlformats.org/officeDocument/2006/relationships" xmlns:p="http://schemas.openxmlformats.org/presentationml/2006/main">
+<p:notes xmlns:a="http://schemas.openxmlformats.org/drawingml/2006/main" xmlns:p="http://schemas.openxmlformats.org/presentationml/2006/main">
   <p:cSld>
     <p:spTree>
       <p:nvGrpSpPr>
@@ -404,26 +404,26 @@
           <a:lstStyle/>
           <a:p>
             <a:r>
-              <a:rPr sz="1100">
-                <a:latin typeface="Aptos"/>
-              </a:rPr>
-              <a:t>Introduce Module 3 as the standard for Development-ready escalations. The message should be firm but collaborative: Development wants to help, but incomplete tickets slow everyone down.</a:t>
-            </a:r>
-          </a:p>
-          <a:p>
-            <a:r>
-              <a:rPr sz="1100">
-                <a:latin typeface="Aptos"/>
-              </a:rPr>
-              <a:t>Explain that a good escalation does not need to prove the root cause. It needs to define the problem, scope, evidence, and prior checks clearly enough for the next team to act.</a:t>
-            </a:r>
-          </a:p>
-          <a:p>
-            <a:r>
-              <a:rPr sz="1100">
-                <a:latin typeface="Aptos"/>
-              </a:rPr>
-              <a:t>Transition by telling attendees that the next slides define the required ticket fields and examples of good versus bad escalation quality.</a:t>
+              <a:rPr sz="1100" dirty="0">
+                <a:latin typeface="Aptos"/>
+              </a:rPr>
+              <a:t>Module 3 defines what a Development-ready escalation looks like. Development wants to help, but incomplete tickets slow everyone down.</a:t>
+            </a:r>
+          </a:p>
+          <a:p>
+            <a:r>
+              <a:rPr sz="1100" dirty="0">
+                <a:latin typeface="Aptos"/>
+              </a:rPr>
+              <a:t>A good escalation does not need to prove the root cause. It needs to define the problem, scope, evidence, and prior checks clearly enough for the next team to act.</a:t>
+            </a:r>
+          </a:p>
+          <a:p>
+            <a:r>
+              <a:rPr sz="1100" dirty="0">
+                <a:latin typeface="Aptos"/>
+              </a:rPr>
+              <a:t>The next slides cover the required ticket fields and examples of good versus bad escalation quality.</a:t>
             </a:r>
           </a:p>
         </p:txBody>
@@ -449,7 +449,7 @@
 </file>
 
 <file path=ppt/notesSlides/notesSlide11.xml><?xml version="1.0" encoding="utf-8"?>
-<p:notes xmlns:a="http://schemas.openxmlformats.org/drawingml/2006/main" xmlns:r="http://schemas.openxmlformats.org/officeDocument/2006/relationships" xmlns:p="http://schemas.openxmlformats.org/presentationml/2006/main">
+<p:notes xmlns:a="http://schemas.openxmlformats.org/drawingml/2006/main" xmlns:p="http://schemas.openxmlformats.org/presentationml/2006/main">
   <p:cSld>
     <p:spTree>
       <p:nvGrpSpPr>
@@ -493,26 +493,26 @@
           <a:lstStyle/>
           <a:p>
             <a:r>
-              <a:rPr sz="1100">
-                <a:latin typeface="Aptos"/>
-              </a:rPr>
-              <a:t>Position this slide as the Development escalation checklist. Every escalated ticket should contain these fields or explicitly explain why a field does not apply.</a:t>
-            </a:r>
-          </a:p>
-          <a:p>
-            <a:r>
-              <a:rPr sz="1100">
-                <a:latin typeface="Aptos"/>
-              </a:rPr>
-              <a:t>Explain that the checklist prevents missing information from being discovered after handoff. The goal is to reduce repeated customer follow-up and internal rework.</a:t>
-            </a:r>
-          </a:p>
-          <a:p>
-            <a:r>
-              <a:rPr sz="1100">
-                <a:latin typeface="Aptos"/>
-              </a:rPr>
-              <a:t>Practical reminder: Consider turning this checklist into a ticket template or required macro so Support does not have to rebuild the structure manually each time.</a:t>
+              <a:rPr sz="1100" dirty="0">
+                <a:latin typeface="Aptos"/>
+              </a:rPr>
+              <a:t>This is the Development escalation checklist. Every escalated ticket should contain these fields, or it should explicitly explain why a field does not apply.</a:t>
+            </a:r>
+          </a:p>
+          <a:p>
+            <a:r>
+              <a:rPr sz="1100" dirty="0">
+                <a:latin typeface="Aptos"/>
+              </a:rPr>
+              <a:t>The checklist prevents missing information from being discovered after handoff. The goal is to reduce repeated customer follow-up and internal rework.</a:t>
+            </a:r>
+          </a:p>
+          <a:p>
+            <a:r>
+              <a:rPr sz="1100" dirty="0">
+                <a:latin typeface="Aptos"/>
+              </a:rPr>
+              <a:t>This checklist is a strong candidate for a ticket template or required macro so Support does not have to rebuild the structure manually each time.</a:t>
             </a:r>
           </a:p>
         </p:txBody>
@@ -538,7 +538,7 @@
 </file>
 
 <file path=ppt/notesSlides/notesSlide12.xml><?xml version="1.0" encoding="utf-8"?>
-<p:notes xmlns:a="http://schemas.openxmlformats.org/drawingml/2006/main" xmlns:r="http://schemas.openxmlformats.org/officeDocument/2006/relationships" xmlns:p="http://schemas.openxmlformats.org/presentationml/2006/main">
+<p:notes xmlns:a="http://schemas.openxmlformats.org/drawingml/2006/main" xmlns:p="http://schemas.openxmlformats.org/presentationml/2006/main">
   <p:cSld>
     <p:spTree>
       <p:nvGrpSpPr>
@@ -582,26 +582,26 @@
           <a:lstStyle/>
           <a:p>
             <a:r>
-              <a:rPr sz="1100">
-                <a:latin typeface="Aptos"/>
-              </a:rPr>
-              <a:t>Customer and environment details seem basic, but missing basics cause major delays. Development must know which customer, environment, version, and installation type are involved before interpreting behavior.</a:t>
-            </a:r>
-          </a:p>
-          <a:p>
-            <a:r>
-              <a:rPr sz="1100">
-                <a:latin typeface="Aptos"/>
-              </a:rPr>
-              <a:t>Explain why installation type matters: PACS Only, All-In-One, and Enterprise deployments may differ in routing, services, integrations, and operational ownership.</a:t>
-            </a:r>
-          </a:p>
-          <a:p>
-            <a:r>
-              <a:rPr sz="1100">
-                <a:latin typeface="Aptos"/>
-              </a:rPr>
-              <a:t>Practical reminder: Do not rely on assumptions from the ticket title. Put the customer and environment details in the escalation body where they are immediately visible.</a:t>
+              <a:rPr sz="1100" dirty="0">
+                <a:latin typeface="Aptos"/>
+              </a:rPr>
+              <a:t>Customer and environment details may seem basic, but missing basics cause major delays. Development must know the customer, environment, version, and installation type before interpreting behavior.</a:t>
+            </a:r>
+          </a:p>
+          <a:p>
+            <a:r>
+              <a:rPr sz="1100" dirty="0">
+                <a:latin typeface="Aptos"/>
+              </a:rPr>
+              <a:t>Installation type matters because PACS Only, All-In-One, and Enterprise deployments can differ in routing, services, integrations, and operational ownership.</a:t>
+            </a:r>
+          </a:p>
+          <a:p>
+            <a:r>
+              <a:rPr sz="1100" dirty="0">
+                <a:latin typeface="Aptos"/>
+              </a:rPr>
+              <a:t>Do not rely on assumptions from the ticket title. Put the customer and environment details in the escalation body where they are immediately visible.</a:t>
             </a:r>
           </a:p>
         </p:txBody>
@@ -627,7 +627,7 @@
 </file>
 
 <file path=ppt/notesSlides/notesSlide13.xml><?xml version="1.0" encoding="utf-8"?>
-<p:notes xmlns:a="http://schemas.openxmlformats.org/drawingml/2006/main" xmlns:r="http://schemas.openxmlformats.org/officeDocument/2006/relationships" xmlns:p="http://schemas.openxmlformats.org/presentationml/2006/main">
+<p:notes xmlns:a="http://schemas.openxmlformats.org/drawingml/2006/main" xmlns:p="http://schemas.openxmlformats.org/presentationml/2006/main">
   <p:cSld>
     <p:spTree>
       <p:nvGrpSpPr>
@@ -671,7 +671,7 @@
           <a:lstStyle/>
           <a:p>
             <a:r>
-              <a:rPr sz="1100">
+              <a:rPr sz="1100" dirty="0">
                 <a:latin typeface="Aptos"/>
               </a:rPr>
               <a:t>Access and upgrade information removes friction at the start of investigation. If Development cannot access the environment or does not know recent changes, the ticket may pause before technical analysis begins.</a:t>
@@ -679,18 +679,18 @@
           </a:p>
           <a:p>
             <a:r>
-              <a:rPr sz="1100">
-                <a:latin typeface="Aptos"/>
-              </a:rPr>
-              <a:t>Highlight upgrade details because timing matters. Issues that begin immediately after upgrade often relate to release behavior, migration, configuration, cache, or permissions.</a:t>
-            </a:r>
-          </a:p>
-          <a:p>
-            <a:r>
-              <a:rPr sz="1100">
-                <a:latin typeface="Aptos"/>
-              </a:rPr>
-              <a:t>Practical reminder: If access is restricted, identify the owner and the process. Do not escalate without telling Development how access will be coordinated.</a:t>
+              <a:rPr sz="1100" dirty="0">
+                <a:latin typeface="Aptos"/>
+              </a:rPr>
+              <a:t>Upgrade timing is especially important. Issues that begin immediately after upgrade often relate to release behavior, migration, configuration, cache, or permissions.</a:t>
+            </a:r>
+          </a:p>
+          <a:p>
+            <a:r>
+              <a:rPr sz="1100" dirty="0">
+                <a:latin typeface="Aptos"/>
+              </a:rPr>
+              <a:t>If access is restricted, identify the owner and the process. Do not escalate without telling Development how access will be coordinated.</a:t>
             </a:r>
           </a:p>
         </p:txBody>
@@ -716,7 +716,7 @@
 </file>
 
 <file path=ppt/notesSlides/notesSlide14.xml><?xml version="1.0" encoding="utf-8"?>
-<p:notes xmlns:a="http://schemas.openxmlformats.org/drawingml/2006/main" xmlns:r="http://schemas.openxmlformats.org/officeDocument/2006/relationships" xmlns:p="http://schemas.openxmlformats.org/presentationml/2006/main">
+<p:notes xmlns:a="http://schemas.openxmlformats.org/drawingml/2006/main" xmlns:p="http://schemas.openxmlformats.org/presentationml/2006/main">
   <p:cSld>
     <p:spTree>
       <p:nvGrpSpPr>
@@ -760,7 +760,7 @@
           <a:lstStyle/>
           <a:p>
             <a:r>
-              <a:rPr sz="1100">
+              <a:rPr sz="1100" dirty="0">
                 <a:latin typeface="Aptos"/>
               </a:rPr>
               <a:t>Issue classification is critical because each class has a different next action. Questions need answers or KB articles. Configuration requests need setup guidance. Feature requests need product review. Bugs need evidence and Development investigation.</a:t>
@@ -768,18 +768,18 @@
           </a:p>
           <a:p>
             <a:r>
-              <a:rPr sz="1100">
-                <a:latin typeface="Aptos"/>
-              </a:rPr>
-              <a:t>Walk through the decision tree. If behavior is expected, it is not a bug. If setup is required, it is configuration. If the customer wants new behavior, it is an enhancement. If the system fails against expected behavior, it may be a bug.</a:t>
-            </a:r>
-          </a:p>
-          <a:p>
-            <a:r>
-              <a:rPr sz="1100">
-                <a:latin typeface="Aptos"/>
-              </a:rPr>
-              <a:t>Practical reminder: Misclassification creates delays and frustration. A configuration request escalated as a bug may bounce back; a true bug labeled as a question may not receive proper urgency.</a:t>
+              <a:rPr sz="1100" dirty="0">
+                <a:latin typeface="Aptos"/>
+              </a:rPr>
+              <a:t>Use the decision tree this way: if behavior is expected, it is not a bug. If setup is required, it is configuration. If the customer wants new behavior, it is an enhancement. If the system fails against expected behavior, it may be a bug.</a:t>
+            </a:r>
+          </a:p>
+          <a:p>
+            <a:r>
+              <a:rPr sz="1100" dirty="0">
+                <a:latin typeface="Aptos"/>
+              </a:rPr>
+              <a:t>Misclassification creates delays and frustration. A configuration request escalated as a bug may bounce back, and a true bug labeled as a question may not receive the right urgency.</a:t>
             </a:r>
           </a:p>
         </p:txBody>
@@ -805,7 +805,7 @@
 </file>
 
 <file path=ppt/notesSlides/notesSlide15.xml><?xml version="1.0" encoding="utf-8"?>
-<p:notes xmlns:a="http://schemas.openxmlformats.org/drawingml/2006/main" xmlns:r="http://schemas.openxmlformats.org/officeDocument/2006/relationships" xmlns:p="http://schemas.openxmlformats.org/presentationml/2006/main">
+<p:notes xmlns:a="http://schemas.openxmlformats.org/drawingml/2006/main" xmlns:p="http://schemas.openxmlformats.org/presentationml/2006/main">
   <p:cSld>
     <p:spTree>
       <p:nvGrpSpPr>
@@ -849,7 +849,7 @@
           <a:lstStyle/>
           <a:p>
             <a:r>
-              <a:rPr sz="1100">
+              <a:rPr sz="1100" dirty="0">
                 <a:latin typeface="Aptos"/>
               </a:rPr>
               <a:t>Scope determines almost everything about the next step: priority, owner, reproduction approach, and likely root cause. A single exam problem is investigated differently from an all-user production outage.</a:t>
@@ -857,18 +857,18 @@
           </a:p>
           <a:p>
             <a:r>
-              <a:rPr sz="1100">
-                <a:latin typeface="Aptos"/>
-              </a:rPr>
-              <a:t>Give examples: one user points to permissions or browser; one exam points to data or workflow; all exams points to service, configuration, or systemic defect; one site points to location routing or infrastructure.</a:t>
-            </a:r>
-          </a:p>
-          <a:p>
-            <a:r>
-              <a:rPr sz="1100">
-                <a:latin typeface="Aptos"/>
-              </a:rPr>
-              <a:t>Practical reminder: If scope is unknown, say what has been tested and what still needs confirmation. Unknown scope is acceptable only when the ticket explains the gap and the plan to close it.</a:t>
+              <a:rPr sz="1100" dirty="0">
+                <a:latin typeface="Aptos"/>
+              </a:rPr>
+              <a:t>One user points to permissions or browser. One exam points to data or workflow. All exams point to service, configuration, or systemic defect. One site points to location routing or infrastructure.</a:t>
+            </a:r>
+          </a:p>
+          <a:p>
+            <a:r>
+              <a:rPr sz="1100" dirty="0">
+                <a:latin typeface="Aptos"/>
+              </a:rPr>
+              <a:t>If scope is unknown, say what has been tested and what still needs confirmation. Unknown scope is acceptable only when the ticket explains the gap and the plan to close it.</a:t>
             </a:r>
           </a:p>
         </p:txBody>
@@ -894,7 +894,7 @@
 </file>
 
 <file path=ppt/notesSlides/notesSlide16.xml><?xml version="1.0" encoding="utf-8"?>
-<p:notes xmlns:a="http://schemas.openxmlformats.org/drawingml/2006/main" xmlns:r="http://schemas.openxmlformats.org/officeDocument/2006/relationships" xmlns:p="http://schemas.openxmlformats.org/presentationml/2006/main">
+<p:notes xmlns:a="http://schemas.openxmlformats.org/drawingml/2006/main" xmlns:p="http://schemas.openxmlformats.org/presentationml/2006/main">
   <p:cSld>
     <p:spTree>
       <p:nvGrpSpPr>
@@ -938,7 +938,7 @@
           <a:lstStyle/>
           <a:p>
             <a:r>
-              <a:rPr sz="1100">
+              <a:rPr sz="1100" dirty="0">
                 <a:latin typeface="Aptos"/>
               </a:rPr>
               <a:t>Logs should be relevant, focused, and tied to the issue timeframe. Large log dumps slow investigation and may create privacy or security concerns.</a:t>
@@ -946,18 +946,18 @@
           </a:p>
           <a:p>
             <a:r>
-              <a:rPr sz="1100">
-                <a:latin typeface="Aptos"/>
-              </a:rPr>
-              <a:t>Explain the 10-minute guidance: collect a window before and after the issue so investigators can see setup, failure, and after-effects. Adjust the window for intermittent or long-running jobs when needed.</a:t>
-            </a:r>
-          </a:p>
-          <a:p>
-            <a:r>
-              <a:rPr sz="1100">
-                <a:latin typeface="Aptos"/>
-              </a:rPr>
-              <a:t>Practical reminder: Always include the timezone and exact timestamp of reproduction. A log file without timing context can be difficult to use.</a:t>
+              <a:rPr sz="1100" dirty="0">
+                <a:latin typeface="Aptos"/>
+              </a:rPr>
+              <a:t>For the 10-minute guidance, collect a window before and after the issue so investigators can see setup, failure, and after-effects. Adjust the window for intermittent or long-running jobs when needed.</a:t>
+            </a:r>
+          </a:p>
+          <a:p>
+            <a:r>
+              <a:rPr sz="1100" dirty="0">
+                <a:latin typeface="Aptos"/>
+              </a:rPr>
+              <a:t>Always include the timezone and exact timestamp of reproduction. A log file without timing context can be difficult to use.</a:t>
             </a:r>
           </a:p>
         </p:txBody>
@@ -983,7 +983,7 @@
 </file>
 
 <file path=ppt/notesSlides/notesSlide17.xml><?xml version="1.0" encoding="utf-8"?>
-<p:notes xmlns:a="http://schemas.openxmlformats.org/drawingml/2006/main" xmlns:r="http://schemas.openxmlformats.org/officeDocument/2006/relationships" xmlns:p="http://schemas.openxmlformats.org/presentationml/2006/main">
+<p:notes xmlns:a="http://schemas.openxmlformats.org/drawingml/2006/main" xmlns:p="http://schemas.openxmlformats.org/presentationml/2006/main">
   <p:cSld>
     <p:spTree>
       <p:nvGrpSpPr>
@@ -1027,26 +1027,26 @@
           <a:lstStyle/>
           <a:p>
             <a:r>
-              <a:rPr sz="1100">
-                <a:latin typeface="Aptos"/>
-              </a:rPr>
-              <a:t>Use this comparison to make escalation quality tangible. The bad example is common because it feels urgent, but it gives the next team almost nothing to act on.</a:t>
-            </a:r>
-          </a:p>
-          <a:p>
-            <a:r>
-              <a:rPr sz="1100">
-                <a:latin typeface="Aptos"/>
-              </a:rPr>
-              <a:t>Walk through the good example line by line. It contains customer, version, impact, timing, scope, evidence, KB check, and senior review. Development can immediately decide how to reproduce or inspect logs.</a:t>
-            </a:r>
-          </a:p>
-          <a:p>
-            <a:r>
-              <a:rPr sz="1100">
-                <a:latin typeface="Aptos"/>
-              </a:rPr>
-              <a:t>Discussion prompt: Ask attendees what they would add to the good example for a reporting issue. Expected answers include report ID, exam ID, expected text, actual text, and exact timestamp.</a:t>
+              <a:rPr sz="1100" dirty="0">
+                <a:latin typeface="Aptos"/>
+              </a:rPr>
+              <a:t>This comparison makes escalation quality tangible. The bad example is common because it feels urgent, but it gives the next team almost nothing to act on.</a:t>
+            </a:r>
+          </a:p>
+          <a:p>
+            <a:r>
+              <a:rPr sz="1100" dirty="0">
+                <a:latin typeface="Aptos"/>
+              </a:rPr>
+              <a:t>The good example includes customer, version, impact, timing, scope, evidence, KB check, and senior review. With that information, Development can immediately decide how to reproduce or inspect logs.</a:t>
+            </a:r>
+          </a:p>
+          <a:p>
+            <a:r>
+              <a:rPr sz="1100" dirty="0">
+                <a:latin typeface="Aptos"/>
+              </a:rPr>
+              <a:t>For a reporting issue, we would add details such as report ID, exam ID, expected text, actual text, and exact timestamp.</a:t>
             </a:r>
           </a:p>
         </p:txBody>
@@ -1072,7 +1072,7 @@
 </file>
 
 <file path=ppt/notesSlides/notesSlide18.xml><?xml version="1.0" encoding="utf-8"?>
-<p:notes xmlns:a="http://schemas.openxmlformats.org/drawingml/2006/main" xmlns:r="http://schemas.openxmlformats.org/officeDocument/2006/relationships" xmlns:p="http://schemas.openxmlformats.org/presentationml/2006/main">
+<p:notes xmlns:a="http://schemas.openxmlformats.org/drawingml/2006/main" xmlns:p="http://schemas.openxmlformats.org/presentationml/2006/main">
   <p:cSld>
     <p:spTree>
       <p:nvGrpSpPr>
@@ -1116,26 +1116,26 @@
           <a:lstStyle/>
           <a:p>
             <a:r>
-              <a:rPr sz="1100">
-                <a:latin typeface="Aptos"/>
-              </a:rPr>
-              <a:t>Introduce Module 4 as the prevention layer. Good support organizations reuse knowledge and collaborate before escalating to engineering.</a:t>
-            </a:r>
-          </a:p>
-          <a:p>
-            <a:r>
-              <a:rPr sz="1100">
-                <a:latin typeface="Aptos"/>
-              </a:rPr>
-              <a:t>Explain that KB search and previous ticket review are not optional administrative steps. They identify known workarounds, configuration fixes, release behavior, and prior Development conclusions.</a:t>
-            </a:r>
-          </a:p>
-          <a:p>
-            <a:r>
-              <a:rPr sz="1100">
-                <a:latin typeface="Aptos"/>
-              </a:rPr>
-              <a:t>Practical reminder: If no KB article exists for a recurring issue, Support should flag that as an improvement opportunity. Reducing repeat escalations depends on capturing knowledge after resolution.</a:t>
+              <a:rPr sz="1100" dirty="0">
+                <a:latin typeface="Aptos"/>
+              </a:rPr>
+              <a:t>Module 4 is the prevention layer. Strong support teams reuse knowledge and collaborate internally before escalating to engineering.</a:t>
+            </a:r>
+          </a:p>
+          <a:p>
+            <a:r>
+              <a:rPr sz="1100" dirty="0">
+                <a:latin typeface="Aptos"/>
+              </a:rPr>
+              <a:t>KB search and previous ticket review are not optional administrative steps. They identify known workarounds, configuration fixes, release behavior, and prior Development conclusions.</a:t>
+            </a:r>
+          </a:p>
+          <a:p>
+            <a:r>
+              <a:rPr sz="1100" dirty="0">
+                <a:latin typeface="Aptos"/>
+              </a:rPr>
+              <a:t>If no KB article exists for a recurring issue, flag that as an improvement opportunity. Reducing repeat escalations depends on capturing knowledge after resolution.</a:t>
             </a:r>
           </a:p>
         </p:txBody>
@@ -1161,7 +1161,7 @@
 </file>
 
 <file path=ppt/notesSlides/notesSlide19.xml><?xml version="1.0" encoding="utf-8"?>
-<p:notes xmlns:a="http://schemas.openxmlformats.org/drawingml/2006/main" xmlns:r="http://schemas.openxmlformats.org/officeDocument/2006/relationships" xmlns:p="http://schemas.openxmlformats.org/presentationml/2006/main">
+<p:notes xmlns:a="http://schemas.openxmlformats.org/drawingml/2006/main" xmlns:p="http://schemas.openxmlformats.org/presentationml/2006/main">
   <p:cSld>
     <p:spTree>
       <p:nvGrpSpPr>
@@ -1205,26 +1205,26 @@
           <a:lstStyle/>
           <a:p>
             <a:r>
-              <a:rPr sz="1100">
-                <a:latin typeface="Aptos"/>
-              </a:rPr>
-              <a:t>Summarize the expected outcomes as observable behaviors. After this training, Support should classify issues correctly, complete standard checks, gather focused evidence, use the KB, consult internal experts, and escalate with quality.</a:t>
-            </a:r>
-          </a:p>
-          <a:p>
-            <a:r>
-              <a:rPr sz="1100">
-                <a:latin typeface="Aptos"/>
-              </a:rPr>
-              <a:t>Emphasize that this is a continuous improvement loop. Each resolved ticket should improve future troubleshooting through KB updates, better templates, and stronger examples.</a:t>
-            </a:r>
-          </a:p>
-          <a:p>
-            <a:r>
-              <a:rPr sz="1100">
-                <a:latin typeface="Aptos"/>
-              </a:rPr>
-              <a:t>Practical reminder: Encourage the team to use the slides as a desk reference. The checklists are designed to be reused in real tickets, not only remembered from the session.</a:t>
+              <a:rPr sz="1100" dirty="0">
+                <a:latin typeface="Aptos"/>
+              </a:rPr>
+              <a:t>By the end of this training, the expected behaviors are clear. We should classify issues correctly, complete standard troubleshooting, gather focused evidence, use the KB, consult internal experts, and escalate with quality.</a:t>
+            </a:r>
+          </a:p>
+          <a:p>
+            <a:r>
+              <a:rPr sz="1100" dirty="0">
+                <a:latin typeface="Aptos"/>
+              </a:rPr>
+              <a:t>This is also a continuous improvement loop. Each resolved ticket should improve future troubleshooting through KB updates, better templates, and stronger examples.</a:t>
+            </a:r>
+          </a:p>
+          <a:p>
+            <a:r>
+              <a:rPr sz="1100" dirty="0">
+                <a:latin typeface="Aptos"/>
+              </a:rPr>
+              <a:t>Use these slides as a desk reference after today. The checklists are designed to be reused in real tickets, not only remembered from the session.</a:t>
             </a:r>
           </a:p>
         </p:txBody>
@@ -1250,7 +1250,7 @@
 </file>
 
 <file path=ppt/notesSlides/notesSlide2.xml><?xml version="1.0" encoding="utf-8"?>
-<p:notes xmlns:a="http://schemas.openxmlformats.org/drawingml/2006/main" xmlns:r="http://schemas.openxmlformats.org/officeDocument/2006/relationships" xmlns:p="http://schemas.openxmlformats.org/presentationml/2006/main">
+<p:notes xmlns:a="http://schemas.openxmlformats.org/drawingml/2006/main" xmlns:p="http://schemas.openxmlformats.org/presentationml/2006/main">
   <p:cSld>
     <p:spTree>
       <p:nvGrpSpPr>
@@ -1294,26 +1294,26 @@
           <a:lstStyle/>
           <a:p>
             <a:r>
-              <a:rPr sz="1100">
-                <a:latin typeface="Aptos"/>
-              </a:rPr>
-              <a:t>Explain that this training is designed around day-to-day support behavior: how tickets are classified, how evidence is gathered, how internal expertise is used, and when Development should be engaged.</a:t>
-            </a:r>
-          </a:p>
-          <a:p>
-            <a:r>
-              <a:rPr sz="1100">
-                <a:latin typeface="Aptos"/>
-              </a:rPr>
-              <a:t>Use a real-world framing: Development can only move quickly when the issue is scoped, evidence is complete, and the customer scenario is clear. A ticket that says “not working” creates delay even when the underlying issue is important.</a:t>
-            </a:r>
-          </a:p>
-          <a:p>
-            <a:r>
-              <a:rPr sz="1100">
-                <a:latin typeface="Aptos"/>
-              </a:rPr>
-              <a:t>Invite the audience to treat each section as a checklist they can apply immediately after the session. The expected outcome is not perfection; it is consistency and fewer avoidable escalations.</a:t>
+              <a:rPr sz="1100" dirty="0">
+                <a:latin typeface="Aptos"/>
+              </a:rPr>
+              <a:t>This training is about the behaviors we use every day: how we classify tickets, gather evidence, use internal expertise, and decide when Development should be engaged.</a:t>
+            </a:r>
+          </a:p>
+          <a:p>
+            <a:r>
+              <a:rPr sz="1100" dirty="0">
+                <a:latin typeface="Aptos"/>
+              </a:rPr>
+              <a:t>Development can move quickly only when the issue is scoped, the evidence is complete, and the customer scenario is clear. A ticket that only says ‘not working’ creates delay, even when the underlying issue is important.</a:t>
+            </a:r>
+          </a:p>
+          <a:p>
+            <a:r>
+              <a:rPr sz="1100" dirty="0">
+                <a:latin typeface="Aptos"/>
+              </a:rPr>
+              <a:t>Treat each section as a checklist you can apply immediately after this session. The goal is not perfection; the goal is consistency and fewer avoidable escalations.</a:t>
             </a:r>
           </a:p>
         </p:txBody>
@@ -1339,7 +1339,7 @@
 </file>
 
 <file path=ppt/notesSlides/notesSlide20.xml><?xml version="1.0" encoding="utf-8"?>
-<p:notes xmlns:a="http://schemas.openxmlformats.org/drawingml/2006/main" xmlns:r="http://schemas.openxmlformats.org/officeDocument/2006/relationships" xmlns:p="http://schemas.openxmlformats.org/presentationml/2006/main">
+<p:notes xmlns:a="http://schemas.openxmlformats.org/drawingml/2006/main" xmlns:p="http://schemas.openxmlformats.org/presentationml/2006/main">
   <p:cSld>
     <p:spTree>
       <p:nvGrpSpPr>
@@ -1383,26 +1383,26 @@
           <a:lstStyle/>
           <a:p>
             <a:r>
-              <a:rPr sz="1100">
-                <a:latin typeface="Aptos"/>
-              </a:rPr>
-              <a:t>Use the Q&amp;A to turn the training into action. Start with current escalation pain points: common issue types, missing information, delays, and repeated questions from Development.</a:t>
-            </a:r>
-          </a:p>
-          <a:p>
-            <a:r>
-              <a:rPr sz="1100">
-                <a:latin typeface="Aptos"/>
-              </a:rPr>
-              <a:t>Capture improvement ideas during discussion. Strong candidates include ticket template updates, KB article creation, training refreshers, quick-reference checklists, and better release note summaries.</a:t>
-            </a:r>
-          </a:p>
-          <a:p>
-            <a:r>
-              <a:rPr sz="1100">
-                <a:latin typeface="Aptos"/>
-              </a:rPr>
-              <a:t>Close by reinforcing partnership. The goal is not to reduce escalations by ignoring issues; the goal is to reduce unnecessary escalations and improve the quality of necessary ones.</a:t>
+              <a:rPr sz="1100" dirty="0">
+                <a:latin typeface="Aptos"/>
+              </a:rPr>
+              <a:t>For Q&amp;A, let’s turn the training into action. What issue types are most commonly escalated today? What information is usually missing? Where do delays happen? What questions does Development ask repeatedly?</a:t>
+            </a:r>
+          </a:p>
+          <a:p>
+            <a:r>
+              <a:rPr sz="1100" dirty="0">
+                <a:latin typeface="Aptos"/>
+              </a:rPr>
+              <a:t>As we discuss, capture improvement ideas. Strong candidates include ticket template updates, KB article creation, training refreshers, quick-reference checklists, and better release note summaries.</a:t>
+            </a:r>
+          </a:p>
+          <a:p>
+            <a:r>
+              <a:rPr sz="1100" dirty="0">
+                <a:latin typeface="Aptos"/>
+              </a:rPr>
+              <a:t>The goal is not to reduce escalations by ignoring issues. The goal is to reduce unnecessary escalations and improve the quality of necessary ones.</a:t>
             </a:r>
           </a:p>
         </p:txBody>
@@ -1428,7 +1428,7 @@
 </file>
 
 <file path=ppt/notesSlides/notesSlide3.xml><?xml version="1.0" encoding="utf-8"?>
-<p:notes xmlns:a="http://schemas.openxmlformats.org/drawingml/2006/main" xmlns:r="http://schemas.openxmlformats.org/officeDocument/2006/relationships" xmlns:p="http://schemas.openxmlformats.org/presentationml/2006/main">
+<p:notes xmlns:a="http://schemas.openxmlformats.org/drawingml/2006/main" xmlns:p="http://schemas.openxmlformats.org/presentationml/2006/main">
   <p:cSld>
     <p:spTree>
       <p:nvGrpSpPr>
@@ -1472,26 +1472,26 @@
           <a:lstStyle/>
           <a:p>
             <a:r>
-              <a:rPr sz="1100">
-                <a:latin typeface="Aptos"/>
-              </a:rPr>
-              <a:t>Walk through the agenda and connect each module to the escalation lifecycle. Release awareness helps identify expected behavior. Troubleshooting and investigation establish facts. Escalation standards make the handoff actionable. Knowledge Base and collaboration reduce repeat escalations.</a:t>
-            </a:r>
-          </a:p>
-          <a:p>
-            <a:r>
-              <a:rPr sz="1100">
-                <a:latin typeface="Aptos"/>
-              </a:rPr>
-              <a:t>Tell attendees that the timing is flexible depending on discussion. If there are current high-volume issue types, use them as examples during Module 2 and Module 3.</a:t>
-            </a:r>
-          </a:p>
-          <a:p>
-            <a:r>
-              <a:rPr sz="1100">
-                <a:latin typeface="Aptos"/>
-              </a:rPr>
-              <a:t>Reinforce that Q&amp;A is intentionally included at the end, but questions during the session are welcome when they clarify a process or checklist.</a:t>
+              <a:rPr sz="1100" dirty="0">
+                <a:latin typeface="Aptos"/>
+              </a:rPr>
+              <a:t>Here is the agenda for today. Release awareness helps us identify expected behavior. Troubleshooting and investigation establish facts. Escalation standards make the handoff actionable. Knowledge Base usage and collaboration reduce repeat escalations.</a:t>
+            </a:r>
+          </a:p>
+          <a:p>
+            <a:r>
+              <a:rPr sz="1100" dirty="0">
+                <a:latin typeface="Aptos"/>
+              </a:rPr>
+              <a:t>The timing is flexible depending on discussion. If we have current high-volume issue types, we will use them as examples during the troubleshooting and escalation sections.</a:t>
+            </a:r>
+          </a:p>
+          <a:p>
+            <a:r>
+              <a:rPr sz="1100" dirty="0">
+                <a:latin typeface="Aptos"/>
+              </a:rPr>
+              <a:t>We have Q&amp;A at the end, but please ask questions during the session when they clarify a process, checklist, or example.</a:t>
             </a:r>
           </a:p>
         </p:txBody>
@@ -1517,7 +1517,7 @@
 </file>
 
 <file path=ppt/notesSlides/notesSlide4.xml><?xml version="1.0" encoding="utf-8"?>
-<p:notes xmlns:a="http://schemas.openxmlformats.org/drawingml/2006/main" xmlns:r="http://schemas.openxmlformats.org/officeDocument/2006/relationships" xmlns:p="http://schemas.openxmlformats.org/presentationml/2006/main">
+<p:notes xmlns:a="http://schemas.openxmlformats.org/drawingml/2006/main" xmlns:p="http://schemas.openxmlformats.org/presentationml/2006/main">
   <p:cSld>
     <p:spTree>
       <p:nvGrpSpPr>
@@ -1561,26 +1561,26 @@
           <a:lstStyle/>
           <a:p>
             <a:r>
-              <a:rPr sz="1100">
-                <a:latin typeface="Aptos"/>
-              </a:rPr>
-              <a:t>Introduce Module 1 as the foundation for post-release support. Many tickets that look like defects are actually changed behavior, new validations, configuration gaps, or permission changes introduced by a release.</a:t>
-            </a:r>
-          </a:p>
-          <a:p>
-            <a:r>
-              <a:rPr sz="1100">
-                <a:latin typeface="Aptos"/>
-              </a:rPr>
-              <a:t>Emphasize that Support does not need to memorize every line of every release note. The practical approach is to group changes by business area and understand which customer workflows may be affected.</a:t>
-            </a:r>
-          </a:p>
-          <a:p>
-            <a:r>
-              <a:rPr sz="1100">
-                <a:latin typeface="Aptos"/>
-              </a:rPr>
-              <a:t>Discussion prompt: Ask the group which release changes usually generate the most tickets: reporting, exams, interfaces, filters, or permissions. Use responses to make the module concrete.</a:t>
+              <a:rPr sz="1100" dirty="0">
+                <a:latin typeface="Aptos"/>
+              </a:rPr>
+              <a:t>Module 1 starts with product release updates because release awareness is the foundation for post-release support. Many tickets that look like defects are actually changed behavior, new validations, configuration gaps, or permission changes introduced by a release.</a:t>
+            </a:r>
+          </a:p>
+          <a:p>
+            <a:r>
+              <a:rPr sz="1100" dirty="0">
+                <a:latin typeface="Aptos"/>
+              </a:rPr>
+              <a:t>We do not need to memorize every line of every release note. The practical approach is to group changes by business area and understand which customer workflows may be affected.</a:t>
+            </a:r>
+          </a:p>
+          <a:p>
+            <a:r>
+              <a:rPr sz="1100" dirty="0">
+                <a:latin typeface="Aptos"/>
+              </a:rPr>
+              <a:t>Before we continue, think about which release changes usually generate the most tickets for us: reporting, exams, interfaces, filters, or permissions. Those examples will make this module more concrete.</a:t>
             </a:r>
           </a:p>
         </p:txBody>
@@ -1606,7 +1606,7 @@
 </file>
 
 <file path=ppt/notesSlides/notesSlide5.xml><?xml version="1.0" encoding="utf-8"?>
-<p:notes xmlns:a="http://schemas.openxmlformats.org/drawingml/2006/main" xmlns:r="http://schemas.openxmlformats.org/officeDocument/2006/relationships" xmlns:p="http://schemas.openxmlformats.org/presentationml/2006/main">
+<p:notes xmlns:a="http://schemas.openxmlformats.org/drawingml/2006/main" xmlns:p="http://schemas.openxmlformats.org/presentationml/2006/main">
   <p:cSld>
     <p:spTree>
       <p:nvGrpSpPr>
@@ -1653,7 +1653,7 @@
               <a:rPr sz="1100" dirty="0">
                 <a:latin typeface="Aptos"/>
               </a:rPr>
-              <a:t>Explain the five business areas as the mental model for reviewing a release. Each area maps to common customer symptoms: missing exams, reporting differences, interface failures, performance issues, or access/security changes.</a:t>
+              <a:t>I want us to use these five business areas as the mental model for reviewing a release. Each area maps to common customer symptoms: missing exams, reporting differences, interface failures, performance issues, or access and security changes.</a:t>
             </a:r>
           </a:p>
           <a:p>
@@ -1661,7 +1661,7 @@
               <a:rPr sz="1100" dirty="0">
                 <a:latin typeface="Aptos"/>
               </a:rPr>
-              <a:t>Encourage Support to tag or categorize post-release tickets using these areas. This helps identify whether a spike is isolated, customer-specific, or a broader release adoption issue.</a:t>
+              <a:t>When post-release tickets come in, categorize them using these areas. That helps us see whether a spike is isolated, customer-specific, or part of a broader release adoption issue.</a:t>
             </a:r>
           </a:p>
           <a:p>
@@ -1669,7 +1669,7 @@
               <a:rPr sz="1100" dirty="0">
                 <a:latin typeface="Aptos"/>
               </a:rPr>
-              <a:t>Practical reminder: When a customer reports a new issue after upgrade, capture the business area and version immediately. Those two facts often determine the first troubleshooting path.</a:t>
+              <a:t>When a customer reports a new issue after an upgrade, capture the business area and version immediately. Those two facts often determine the first troubleshooting path.</a:t>
             </a:r>
           </a:p>
         </p:txBody>
@@ -1695,7 +1695,7 @@
 </file>
 
 <file path=ppt/notesSlides/notesSlide6.xml><?xml version="1.0" encoding="utf-8"?>
-<p:notes xmlns:a="http://schemas.openxmlformats.org/drawingml/2006/main" xmlns:r="http://schemas.openxmlformats.org/officeDocument/2006/relationships" xmlns:p="http://schemas.openxmlformats.org/presentationml/2006/main">
+<p:notes xmlns:a="http://schemas.openxmlformats.org/drawingml/2006/main" xmlns:p="http://schemas.openxmlformats.org/presentationml/2006/main">
   <p:cSld>
     <p:spTree>
       <p:nvGrpSpPr>
@@ -1739,26 +1739,26 @@
           <a:lstStyle/>
           <a:p>
             <a:r>
-              <a:rPr sz="1100">
-                <a:latin typeface="Aptos"/>
-              </a:rPr>
-              <a:t>Summarize Module 1 by reinforcing the core mindset: after a release, Support should investigate whether behavior is expected, configuration-dependent, or permission-related before treating it as a defect.</a:t>
-            </a:r>
-          </a:p>
-          <a:p>
-            <a:r>
-              <a:rPr sz="1100">
-                <a:latin typeface="Aptos"/>
-              </a:rPr>
-              <a:t>Use examples from earlier slides: missing exams may be filters or permissions; reporting differences may be macro or worksheet flow; integration failures may be endpoint or routing changes.</a:t>
-            </a:r>
-          </a:p>
-          <a:p>
-            <a:r>
-              <a:rPr sz="1100">
-                <a:latin typeface="Aptos"/>
-              </a:rPr>
-              <a:t>Transition to Module 2 by explaining that release awareness is only one input. The next module covers the structured troubleshooting method that applies to all issue types.</a:t>
+              <a:rPr sz="1100" dirty="0">
+                <a:latin typeface="Aptos"/>
+              </a:rPr>
+              <a:t>The key takeaway from Module 1 is that not every behavior change is a bug. After a release, we should first determine whether the behavior is expected, configuration-dependent, or permission-related.</a:t>
+            </a:r>
+          </a:p>
+          <a:p>
+            <a:r>
+              <a:rPr sz="1100" dirty="0">
+                <a:latin typeface="Aptos"/>
+              </a:rPr>
+              <a:t>Think back to the examples we covered: missing exams may be filters or permissions, reporting differences may be macro or worksheet flow, and integration failures may be endpoint or routing changes.</a:t>
+            </a:r>
+          </a:p>
+          <a:p>
+            <a:r>
+              <a:rPr sz="1100" dirty="0">
+                <a:latin typeface="Aptos"/>
+              </a:rPr>
+              <a:t>Release awareness is only one input. Next, we will move into the structured troubleshooting method that applies to every issue type.</a:t>
             </a:r>
           </a:p>
         </p:txBody>
@@ -1784,7 +1784,7 @@
 </file>
 
 <file path=ppt/notesSlides/notesSlide7.xml><?xml version="1.0" encoding="utf-8"?>
-<p:notes xmlns:a="http://schemas.openxmlformats.org/drawingml/2006/main" xmlns:r="http://schemas.openxmlformats.org/officeDocument/2006/relationships" xmlns:p="http://schemas.openxmlformats.org/presentationml/2006/main">
+<p:notes xmlns:a="http://schemas.openxmlformats.org/drawingml/2006/main" xmlns:p="http://schemas.openxmlformats.org/presentationml/2006/main">
   <p:cSld>
     <p:spTree>
       <p:nvGrpSpPr>
@@ -1828,26 +1828,26 @@
           <a:lstStyle/>
           <a:p>
             <a:r>
-              <a:rPr sz="1100">
-                <a:latin typeface="Aptos"/>
-              </a:rPr>
-              <a:t>Introduce troubleshooting as the highest-leverage support skill. A strong L1 investigation can resolve simple issues immediately and make complex issues easier for L2 or Development to act on.</a:t>
-            </a:r>
-          </a:p>
-          <a:p>
-            <a:r>
-              <a:rPr sz="1100">
-                <a:latin typeface="Aptos"/>
-              </a:rPr>
-              <a:t>Emphasize that structured troubleshooting protects the customer experience. It avoids random checks, repeated questions, and unnecessary escalation delays.</a:t>
-            </a:r>
-          </a:p>
-          <a:p>
-            <a:r>
-              <a:rPr sz="1100">
-                <a:latin typeface="Aptos"/>
-              </a:rPr>
-              <a:t>Discussion prompt: Ask attendees what happens when scope is not established early. Guide them toward common consequences: wrong priority, wrong team, missing logs, and repeated customer follow-up.</a:t>
+              <a:rPr sz="1100" dirty="0">
+                <a:latin typeface="Aptos"/>
+              </a:rPr>
+              <a:t>Troubleshooting is one of the highest-leverage support skills. A strong L1 investigation can resolve simple issues immediately and make complex issues easier for L2 or Development to act on.</a:t>
+            </a:r>
+          </a:p>
+          <a:p>
+            <a:r>
+              <a:rPr sz="1100" dirty="0">
+                <a:latin typeface="Aptos"/>
+              </a:rPr>
+              <a:t>Structured troubleshooting protects the customer experience. It prevents random checks, repeated questions, and unnecessary escalation delays.</a:t>
+            </a:r>
+          </a:p>
+          <a:p>
+            <a:r>
+              <a:rPr sz="1100" dirty="0">
+                <a:latin typeface="Aptos"/>
+              </a:rPr>
+              <a:t>When scope is not established early, we can assign the wrong priority, involve the wrong team, miss the right logs, and create repeated customer follow-up.</a:t>
             </a:r>
           </a:p>
         </p:txBody>
@@ -1873,7 +1873,7 @@
 </file>
 
 <file path=ppt/notesSlides/notesSlide8.xml><?xml version="1.0" encoding="utf-8"?>
-<p:notes xmlns:a="http://schemas.openxmlformats.org/drawingml/2006/main" xmlns:r="http://schemas.openxmlformats.org/officeDocument/2006/relationships" xmlns:p="http://schemas.openxmlformats.org/presentationml/2006/main">
+<p:notes xmlns:a="http://schemas.openxmlformats.org/drawingml/2006/main" xmlns:p="http://schemas.openxmlformats.org/presentationml/2006/main">
   <p:cSld>
     <p:spTree>
       <p:nvGrpSpPr>
@@ -1917,26 +1917,26 @@
           <a:lstStyle/>
           <a:p>
             <a:r>
-              <a:rPr sz="1100">
-                <a:latin typeface="Aptos"/>
-              </a:rPr>
-              <a:t>This slide is the core investigation checklist. Walk through each question and explain that none are optional for a quality escalation.</a:t>
-            </a:r>
-          </a:p>
-          <a:p>
-            <a:r>
-              <a:rPr sz="1100">
-                <a:latin typeface="Aptos"/>
-              </a:rPr>
-              <a:t>Use a simple example: “Report not working” becomes actionable only when Support knows which report, which user, when it started, which environment, and whether all reports or only one exam type are affected.</a:t>
-            </a:r>
-          </a:p>
-          <a:p>
-            <a:r>
-              <a:rPr sz="1100">
-                <a:latin typeface="Aptos"/>
-              </a:rPr>
-              <a:t>Practical reminder: These questions should be answered in the ticket body, not hidden in chat threads. The ticket should tell the next engineer exactly what is known.</a:t>
+              <a:rPr sz="1100" dirty="0">
+                <a:latin typeface="Aptos"/>
+              </a:rPr>
+              <a:t>This is the core investigation checklist. For a quality escalation, we need to answer what is failing, who is affected, when it started, where it happens, and what the scope is.</a:t>
+            </a:r>
+          </a:p>
+          <a:p>
+            <a:r>
+              <a:rPr sz="1100" dirty="0">
+                <a:latin typeface="Aptos"/>
+              </a:rPr>
+              <a:t>A statement like ‘Report not working’ becomes actionable only when we know which report, which user, when it started, which environment, and whether all reports or only one exam type are affected.</a:t>
+            </a:r>
+          </a:p>
+          <a:p>
+            <a:r>
+              <a:rPr sz="1100" dirty="0">
+                <a:latin typeface="Aptos"/>
+              </a:rPr>
+              <a:t>These answers belong in the ticket body, not hidden in chat threads. The ticket should tell the next engineer exactly what is known.</a:t>
             </a:r>
           </a:p>
         </p:txBody>
@@ -1962,7 +1962,7 @@
 </file>
 
 <file path=ppt/notesSlides/notesSlide9.xml><?xml version="1.0" encoding="utf-8"?>
-<p:notes xmlns:a="http://schemas.openxmlformats.org/drawingml/2006/main" xmlns:r="http://schemas.openxmlformats.org/officeDocument/2006/relationships" xmlns:p="http://schemas.openxmlformats.org/presentationml/2006/main">
+<p:notes xmlns:a="http://schemas.openxmlformats.org/drawingml/2006/main" xmlns:p="http://schemas.openxmlformats.org/presentationml/2006/main">
   <p:cSld>
     <p:spTree>
       <p:nvGrpSpPr>
@@ -2006,26 +2006,26 @@
           <a:lstStyle/>
           <a:p>
             <a:r>
-              <a:rPr sz="1100">
-                <a:latin typeface="Aptos"/>
-              </a:rPr>
-              <a:t>Use the matrix to show how the same investigation principle changes by issue type. The first goal is always to distinguish isolated impact from broad impact.</a:t>
-            </a:r>
-          </a:p>
-          <a:p>
-            <a:r>
-              <a:rPr sz="1100">
-                <a:latin typeface="Aptos"/>
-              </a:rPr>
-              <a:t>For each row, ask what evidence would support the answer. Login may need user comparison. HL7 may need message IDs and queue status. Viewer may need workstation and browser details. Database may need operation type and timing.</a:t>
-            </a:r>
-          </a:p>
-          <a:p>
-            <a:r>
-              <a:rPr sz="1100">
-                <a:latin typeface="Aptos"/>
-              </a:rPr>
-              <a:t>Practical reminder: The matrix can be used as a triage script. It helps Support ask fewer but better questions during the first customer interaction.</a:t>
+              <a:rPr sz="1100" dirty="0">
+                <a:latin typeface="Aptos"/>
+              </a:rPr>
+              <a:t>This matrix shows how the same investigation principle changes by issue type. Our first goal is always to distinguish isolated impact from broad impact.</a:t>
+            </a:r>
+          </a:p>
+          <a:p>
+            <a:r>
+              <a:rPr sz="1100" dirty="0">
+                <a:latin typeface="Aptos"/>
+              </a:rPr>
+              <a:t>For each row, think about the evidence that proves the answer. Login may need a user comparison. HL7 may need message IDs and queue status. Viewer issues may need workstation and browser details. Database symptoms may need operation type and timing.</a:t>
+            </a:r>
+          </a:p>
+          <a:p>
+            <a:r>
+              <a:rPr sz="1100" dirty="0">
+                <a:latin typeface="Aptos"/>
+              </a:rPr>
+              <a:t>Use this matrix as a triage script. It helps us ask fewer questions, but better questions, during the first customer interaction.</a:t>
             </a:r>
           </a:p>
         </p:txBody>

</xml_diff>